<commit_message>
Update paper with 24-case analysis
</commit_message>
<xml_diff>
--- a/figures/pipeline_image.pptx
+++ b/figures/pipeline_image.pptx
@@ -208,7 +208,7 @@
           <a:p>
             <a:fld id="{0D1533CD-6048-664A-89D7-1D26EF37752C}" type="datetimeFigureOut">
               <a:rPr lang="en-US" smtClean="0"/>
-              <a:t>7/22/26</a:t>
+              <a:t>8/15/26</a:t>
             </a:fld>
             <a:endParaRPr lang="en-US"/>
           </a:p>
@@ -738,7 +738,7 @@
           <a:p>
             <a:fld id="{5BCAD085-E8A6-8845-BD4E-CB4CCA059FC4}" type="datetimeFigureOut">
               <a:rPr lang="en-US" smtClean="0"/>
-              <a:t>7/22/26</a:t>
+              <a:t>8/15/26</a:t>
             </a:fld>
             <a:endParaRPr lang="en-US"/>
           </a:p>
@@ -906,7 +906,7 @@
           <a:p>
             <a:fld id="{5BCAD085-E8A6-8845-BD4E-CB4CCA059FC4}" type="datetimeFigureOut">
               <a:rPr lang="en-US" smtClean="0"/>
-              <a:t>7/22/26</a:t>
+              <a:t>8/15/26</a:t>
             </a:fld>
             <a:endParaRPr lang="en-US"/>
           </a:p>
@@ -1084,7 +1084,7 @@
           <a:p>
             <a:fld id="{5BCAD085-E8A6-8845-BD4E-CB4CCA059FC4}" type="datetimeFigureOut">
               <a:rPr lang="en-US" smtClean="0"/>
-              <a:t>7/22/26</a:t>
+              <a:t>8/15/26</a:t>
             </a:fld>
             <a:endParaRPr lang="en-US"/>
           </a:p>
@@ -1252,7 +1252,7 @@
           <a:p>
             <a:fld id="{5BCAD085-E8A6-8845-BD4E-CB4CCA059FC4}" type="datetimeFigureOut">
               <a:rPr lang="en-US" smtClean="0"/>
-              <a:t>7/22/26</a:t>
+              <a:t>8/15/26</a:t>
             </a:fld>
             <a:endParaRPr lang="en-US"/>
           </a:p>
@@ -1497,7 +1497,7 @@
           <a:p>
             <a:fld id="{5BCAD085-E8A6-8845-BD4E-CB4CCA059FC4}" type="datetimeFigureOut">
               <a:rPr lang="en-US" smtClean="0"/>
-              <a:t>7/22/26</a:t>
+              <a:t>8/15/26</a:t>
             </a:fld>
             <a:endParaRPr lang="en-US"/>
           </a:p>
@@ -1782,7 +1782,7 @@
           <a:p>
             <a:fld id="{5BCAD085-E8A6-8845-BD4E-CB4CCA059FC4}" type="datetimeFigureOut">
               <a:rPr lang="en-US" smtClean="0"/>
-              <a:t>7/22/26</a:t>
+              <a:t>8/15/26</a:t>
             </a:fld>
             <a:endParaRPr lang="en-US"/>
           </a:p>
@@ -2201,7 +2201,7 @@
           <a:p>
             <a:fld id="{5BCAD085-E8A6-8845-BD4E-CB4CCA059FC4}" type="datetimeFigureOut">
               <a:rPr lang="en-US" smtClean="0"/>
-              <a:t>7/22/26</a:t>
+              <a:t>8/15/26</a:t>
             </a:fld>
             <a:endParaRPr lang="en-US"/>
           </a:p>
@@ -2318,7 +2318,7 @@
           <a:p>
             <a:fld id="{5BCAD085-E8A6-8845-BD4E-CB4CCA059FC4}" type="datetimeFigureOut">
               <a:rPr lang="en-US" smtClean="0"/>
-              <a:t>7/22/26</a:t>
+              <a:t>8/15/26</a:t>
             </a:fld>
             <a:endParaRPr lang="en-US"/>
           </a:p>
@@ -2413,7 +2413,7 @@
           <a:p>
             <a:fld id="{5BCAD085-E8A6-8845-BD4E-CB4CCA059FC4}" type="datetimeFigureOut">
               <a:rPr lang="en-US" smtClean="0"/>
-              <a:t>7/22/26</a:t>
+              <a:t>8/15/26</a:t>
             </a:fld>
             <a:endParaRPr lang="en-US"/>
           </a:p>
@@ -2688,7 +2688,7 @@
           <a:p>
             <a:fld id="{5BCAD085-E8A6-8845-BD4E-CB4CCA059FC4}" type="datetimeFigureOut">
               <a:rPr lang="en-US" smtClean="0"/>
-              <a:t>7/22/26</a:t>
+              <a:t>8/15/26</a:t>
             </a:fld>
             <a:endParaRPr lang="en-US"/>
           </a:p>
@@ -2940,7 +2940,7 @@
           <a:p>
             <a:fld id="{5BCAD085-E8A6-8845-BD4E-CB4CCA059FC4}" type="datetimeFigureOut">
               <a:rPr lang="en-US" smtClean="0"/>
-              <a:t>7/22/26</a:t>
+              <a:t>8/15/26</a:t>
             </a:fld>
             <a:endParaRPr lang="en-US"/>
           </a:p>
@@ -3151,7 +3151,7 @@
           <a:p>
             <a:fld id="{5BCAD085-E8A6-8845-BD4E-CB4CCA059FC4}" type="datetimeFigureOut">
               <a:rPr lang="en-US" smtClean="0"/>
-              <a:t>7/22/26</a:t>
+              <a:t>8/15/26</a:t>
             </a:fld>
             <a:endParaRPr lang="en-US"/>
           </a:p>
@@ -3655,7 +3655,17 @@
                 <a:latin typeface="Calibri" panose="020F0502020204030204" pitchFamily="34" charset="0"/>
                 <a:cs typeface="Calibri" panose="020F0502020204030204" pitchFamily="34" charset="0"/>
               </a:rPr>
-              <a:t>: 14 complaints → 4,146 paragraphs.</a:t>
+              <a:t>: </a:t>
+            </a:r>
+            <a:r>
+              <a:rPr lang="en-US" sz="1500" dirty="0">
+                <a:solidFill>
+                  <a:schemeClr val="tx1"/>
+                </a:solidFill>
+                <a:latin typeface="Calibri" panose="020F0502020204030204" pitchFamily="34" charset="0"/>
+                <a:cs typeface="Calibri" panose="020F0502020204030204" pitchFamily="34" charset="0"/>
+              </a:rPr>
+              <a:t>24 complaints → 9,000 paragraphs.</a:t>
             </a:r>
           </a:p>
           <a:p>
@@ -3691,7 +3701,7 @@
                 <a:latin typeface="Calibri" panose="020F0502020204030204" pitchFamily="34" charset="0"/>
                 <a:cs typeface="Calibri" panose="020F0502020204030204" pitchFamily="34" charset="0"/>
               </a:rPr>
-              <a:t>: 578 </a:t>
+              <a:t>:</a:t>
             </a:r>
             <a:r>
               <a:rPr lang="en-US" sz="1500" dirty="0">
@@ -3701,18 +3711,15 @@
                 <a:latin typeface="Calibri" panose="020F0502020204030204" pitchFamily="34" charset="0"/>
                 <a:cs typeface="Calibri" panose="020F0502020204030204" pitchFamily="34" charset="0"/>
               </a:rPr>
-              <a:t>articles</a:t>
-            </a:r>
-            <a:r>
-              <a:rPr sz="1500" dirty="0">
-                <a:solidFill>
-                  <a:schemeClr val="tx1"/>
-                </a:solidFill>
-                <a:latin typeface="Calibri" panose="020F0502020204030204" pitchFamily="34" charset="0"/>
-                <a:cs typeface="Calibri" panose="020F0502020204030204" pitchFamily="34" charset="0"/>
-              </a:rPr>
-              <a:t> → 21,314 paragraphs.</a:t>
-            </a:r>
+              <a:t> 807 articles → 31,662 paragraphs.</a:t>
+            </a:r>
+            <a:endParaRPr sz="1500" dirty="0">
+              <a:solidFill>
+                <a:schemeClr val="tx1"/>
+              </a:solidFill>
+              <a:latin typeface="Calibri" panose="020F0502020204030204" pitchFamily="34" charset="0"/>
+              <a:cs typeface="Calibri" panose="020F0502020204030204" pitchFamily="34" charset="0"/>
+            </a:endParaRPr>
           </a:p>
         </p:txBody>
       </p:sp>
@@ -4212,7 +4219,7 @@
                 <a:latin typeface="Calibri" panose="020F0502020204030204" pitchFamily="34" charset="0"/>
                 <a:cs typeface="Calibri" panose="020F0502020204030204" pitchFamily="34" charset="0"/>
               </a:rPr>
-              <a:t>Each LLM classifier provided with (1) psychologically-informed instructions and (2) 150 hand-coded few-shot examples</a:t>
+              <a:t>Each LLM classifier provided with (1) psychologically-informed instructions and (2) hand-coded few-shot examples</a:t>
             </a:r>
           </a:p>
           <a:p>
@@ -4228,7 +4235,7 @@
                 <a:latin typeface="Calibri" panose="020F0502020204030204" pitchFamily="34" charset="0"/>
                 <a:cs typeface="Calibri" panose="020F0502020204030204" pitchFamily="34" charset="0"/>
               </a:rPr>
-              <a:t>Few-shot examples: 150 legal paragraphs (legal classifier only) and 150 media paragraphs (media classifier only)</a:t>
+              <a:t>Few-shot examples: 38 legal paragraphs (legal classifier only) and 39 media paragraphs (media classifier only)</a:t>
             </a:r>
           </a:p>
           <a:p>
@@ -4451,14 +4458,14 @@
               <a:t>: Two runs of the LLM classifier for each corpus; </a:t>
             </a:r>
             <a:r>
-              <a:rPr lang="en-US" sz="1500" i="1" dirty="0" err="1">
-                <a:solidFill>
-                  <a:schemeClr val="tx1"/>
-                </a:solidFill>
-                <a:latin typeface="Calibri" panose="020F0502020204030204" pitchFamily="34" charset="0"/>
-                <a:cs typeface="Calibri" panose="020F0502020204030204" pitchFamily="34" charset="0"/>
-              </a:rPr>
-              <a:t>κ</a:t>
+              <a:rPr lang="el-GR" sz="1500" i="1" dirty="0">
+                <a:solidFill>
+                  <a:schemeClr val="tx1"/>
+                </a:solidFill>
+                <a:latin typeface="Calibri" panose="020F0502020204030204" pitchFamily="34" charset="0"/>
+                <a:cs typeface="Calibri" panose="020F0502020204030204" pitchFamily="34" charset="0"/>
+              </a:rPr>
+              <a:t>κ = 0.90 </a:t>
             </a:r>
             <a:r>
               <a:rPr lang="en-US" sz="1500" i="1" dirty="0">
@@ -4468,27 +4475,17 @@
                 <a:latin typeface="Calibri" panose="020F0502020204030204" pitchFamily="34" charset="0"/>
                 <a:cs typeface="Calibri" panose="020F0502020204030204" pitchFamily="34" charset="0"/>
               </a:rPr>
-              <a:t> = </a:t>
-            </a:r>
-            <a:r>
-              <a:rPr lang="en-US" sz="1500" dirty="0">
-                <a:solidFill>
-                  <a:schemeClr val="tx1"/>
-                </a:solidFill>
-                <a:latin typeface="Calibri" panose="020F0502020204030204" pitchFamily="34" charset="0"/>
-                <a:cs typeface="Calibri" panose="020F0502020204030204" pitchFamily="34" charset="0"/>
-              </a:rPr>
-              <a:t>0.90 for legal and </a:t>
-            </a:r>
-            <a:r>
-              <a:rPr lang="en-US" sz="1500" i="1" dirty="0" err="1">
-                <a:solidFill>
-                  <a:schemeClr val="tx1"/>
-                </a:solidFill>
-                <a:latin typeface="Calibri" panose="020F0502020204030204" pitchFamily="34" charset="0"/>
-                <a:cs typeface="Calibri" panose="020F0502020204030204" pitchFamily="34" charset="0"/>
-              </a:rPr>
-              <a:t>κ</a:t>
+              <a:t>for legal and </a:t>
+            </a:r>
+            <a:r>
+              <a:rPr lang="el-GR" sz="1500" i="1" dirty="0">
+                <a:solidFill>
+                  <a:schemeClr val="tx1"/>
+                </a:solidFill>
+                <a:latin typeface="Calibri" panose="020F0502020204030204" pitchFamily="34" charset="0"/>
+                <a:cs typeface="Calibri" panose="020F0502020204030204" pitchFamily="34" charset="0"/>
+              </a:rPr>
+              <a:t>κ = 0.89 </a:t>
             </a:r>
             <a:r>
               <a:rPr lang="en-US" sz="1500" i="1" dirty="0">
@@ -4498,18 +4495,15 @@
                 <a:latin typeface="Calibri" panose="020F0502020204030204" pitchFamily="34" charset="0"/>
                 <a:cs typeface="Calibri" panose="020F0502020204030204" pitchFamily="34" charset="0"/>
               </a:rPr>
-              <a:t> = </a:t>
-            </a:r>
-            <a:r>
-              <a:rPr lang="en-US" sz="1500" dirty="0">
-                <a:solidFill>
-                  <a:schemeClr val="tx1"/>
-                </a:solidFill>
-                <a:latin typeface="Calibri" panose="020F0502020204030204" pitchFamily="34" charset="0"/>
-                <a:cs typeface="Calibri" panose="020F0502020204030204" pitchFamily="34" charset="0"/>
-              </a:rPr>
-              <a:t>0.87 for media</a:t>
-            </a:r>
+              <a:t>for media</a:t>
+            </a:r>
+            <a:endParaRPr lang="en-US" sz="1500" dirty="0">
+              <a:solidFill>
+                <a:schemeClr val="tx1"/>
+              </a:solidFill>
+              <a:latin typeface="Calibri" panose="020F0502020204030204" pitchFamily="34" charset="0"/>
+              <a:cs typeface="Calibri" panose="020F0502020204030204" pitchFamily="34" charset="0"/>
+            </a:endParaRPr>
           </a:p>
           <a:p>
             <a:pPr marL="171450" indent="-171450">
@@ -4602,7 +4596,7 @@
                 <a:latin typeface="Calibri" panose="020F0502020204030204" pitchFamily="34" charset="0"/>
                 <a:cs typeface="Calibri" panose="020F0502020204030204" pitchFamily="34" charset="0"/>
               </a:rPr>
-              <a:t>0.79 for legal and </a:t>
+              <a:t>0.81 for legal and </a:t>
             </a:r>
             <a:r>
               <a:rPr lang="en-US" sz="1500" i="1" dirty="0" err="1">
@@ -4632,7 +4626,7 @@
                 <a:latin typeface="Calibri" panose="020F0502020204030204" pitchFamily="34" charset="0"/>
                 <a:cs typeface="Calibri" panose="020F0502020204030204" pitchFamily="34" charset="0"/>
               </a:rPr>
-              <a:t>0.77 for media </a:t>
+              <a:t>0.80 for media </a:t>
             </a:r>
             <a:endParaRPr sz="1500" dirty="0">
               <a:solidFill>

</xml_diff>